<commit_message>
feat: add enforceable PPT intake and delivery gates
</commit_message>
<xml_diff>
--- a/skills/ksib-management-review-ppt/benchmarks/format-golden-deck/output/KSIB_MBB_FORMAT_GOLDEN_DECK_V1.pptx
+++ b/skills/ksib-management-review-ppt/benchmarks/format-golden-deck/output/KSIB_MBB_FORMAT_GOLDEN_DECK_V1.pptx
@@ -2,18 +2,18 @@
 <file path=ppt/presentation.xml><?xml version="1.0" encoding="utf-8"?>
 <p:presentation xmlns:p="http://schemas.openxmlformats.org/presentationml/2006/main">
   <p:sldMasterIdLst>
-    <p:sldMasterId xmlns:r="http://schemas.openxmlformats.org/officeDocument/2006/relationships" id="2147483648" r:id="R8d6d767c86af4079"/>
+    <p:sldMasterId xmlns:r="http://schemas.openxmlformats.org/officeDocument/2006/relationships" id="2147483648" r:id="Rc34b5ceb0a0f42d9"/>
   </p:sldMasterIdLst>
   <p:notesMasterIdLst>
-    <p:notesMasterId xmlns:r="http://schemas.openxmlformats.org/officeDocument/2006/relationships" r:id="R6b123d8a156241f2"/>
+    <p:notesMasterId xmlns:r="http://schemas.openxmlformats.org/officeDocument/2006/relationships" r:id="R49254b84fe6a47b2"/>
   </p:notesMasterIdLst>
   <p:sldIdLst>
-    <p:sldId xmlns:r="http://schemas.openxmlformats.org/officeDocument/2006/relationships" id="256" r:id="Rf844dd73dae7489e"/>
-    <p:sldId xmlns:r="http://schemas.openxmlformats.org/officeDocument/2006/relationships" id="257" r:id="R9080910e12cc4764"/>
-    <p:sldId xmlns:r="http://schemas.openxmlformats.org/officeDocument/2006/relationships" id="258" r:id="R0e6e70088972429a"/>
-    <p:sldId xmlns:r="http://schemas.openxmlformats.org/officeDocument/2006/relationships" id="259" r:id="Rd6f739d7c1c94537"/>
-    <p:sldId xmlns:r="http://schemas.openxmlformats.org/officeDocument/2006/relationships" id="260" r:id="R2b6844837dbf4eee"/>
-    <p:sldId xmlns:r="http://schemas.openxmlformats.org/officeDocument/2006/relationships" id="261" r:id="Ra4c1c0e3a6dd4209"/>
+    <p:sldId xmlns:r="http://schemas.openxmlformats.org/officeDocument/2006/relationships" id="256" r:id="R815b70c1e2fc4d2e"/>
+    <p:sldId xmlns:r="http://schemas.openxmlformats.org/officeDocument/2006/relationships" id="257" r:id="R58fc0ddd97be45b2"/>
+    <p:sldId xmlns:r="http://schemas.openxmlformats.org/officeDocument/2006/relationships" id="258" r:id="R85633433b83c42cc"/>
+    <p:sldId xmlns:r="http://schemas.openxmlformats.org/officeDocument/2006/relationships" id="259" r:id="Ra3a8b73a25d84729"/>
+    <p:sldId xmlns:r="http://schemas.openxmlformats.org/officeDocument/2006/relationships" id="260" r:id="R74e08f46019f4bfd"/>
+    <p:sldId xmlns:r="http://schemas.openxmlformats.org/officeDocument/2006/relationships" id="261" r:id="Rb9a6f73acc3f44b7"/>
   </p:sldIdLst>
   <p:sldSz cx="12192000" cy="6858000"/>
   <p:notesSz cx="6858000" cy="9144000"/>
@@ -841,7 +841,7 @@
   </p:cSld>
   <p:clrMap bg1="lt1" tx1="dk1" bg2="lt2" tx2="dk2" accent1="accent1" accent2="accent2" accent3="accent3" accent4="accent4" accent5="accent5" accent6="accent6" hlink="hlink" folHlink="folHlink"/>
   <p:sldLayoutIdLst>
-    <p:sldLayoutId xmlns:r="http://schemas.openxmlformats.org/officeDocument/2006/relationships" id="2147483649" r:id="Re9825e782ceb4b43"/>
+    <p:sldLayoutId xmlns:r="http://schemas.openxmlformats.org/officeDocument/2006/relationships" id="2147483649" r:id="R27ab22fbc06647e1"/>
   </p:sldLayoutIdLst>
   <p:txStyles>
     <p:titleStyle>
@@ -1667,7 +1667,7 @@
           <p:cNvPr id="7" name="cover-accent-line">
             <a:extLst xmlns:a="http://schemas.openxmlformats.org/drawingml/2006/main">
               <a:ext uri="{FF2B5EF4-FFF2-40B4-BE49-F238E27FC236}">
-                <a16:creationId xmlns:a16="http://schemas.microsoft.com/office/drawing/2014/main" id="{3D550EB7-359E-41A9-B084-3F9E8BF1786D}"/>
+                <a16:creationId xmlns:a16="http://schemas.microsoft.com/office/drawing/2014/main" id="{9537616C-1C51-48FF-B65A-82806FE5CF1B}"/>
               </a:ext>
             </a:extLst>
           </p:cNvPr>
@@ -1698,7 +1698,7 @@
           <p:cNvPr id="2" name="cover-wordmark">
             <a:extLst xmlns:a="http://schemas.openxmlformats.org/drawingml/2006/main">
               <a:ext uri="{FF2B5EF4-FFF2-40B4-BE49-F238E27FC236}">
-                <a16:creationId xmlns:a16="http://schemas.microsoft.com/office/drawing/2014/main" id="{9E87374E-9028-4267-9D57-6B33EBFC210A}"/>
+                <a16:creationId xmlns:a16="http://schemas.microsoft.com/office/drawing/2014/main" id="{69B8670F-C815-413D-B321-3EACC013D3C0}"/>
               </a:ext>
             </a:extLst>
           </p:cNvPr>
@@ -1753,7 +1753,7 @@
           <p:cNvPr id="3" name="cover-title">
             <a:extLst xmlns:a="http://schemas.openxmlformats.org/drawingml/2006/main">
               <a:ext uri="{FF2B5EF4-FFF2-40B4-BE49-F238E27FC236}">
-                <a16:creationId xmlns:a16="http://schemas.microsoft.com/office/drawing/2014/main" id="{0D84F858-2501-401D-A004-60A5393ADC2C}"/>
+                <a16:creationId xmlns:a16="http://schemas.microsoft.com/office/drawing/2014/main" id="{6AF90C0D-BA30-41CA-B51A-0BC6ECC4640D}"/>
               </a:ext>
             </a:extLst>
           </p:cNvPr>
@@ -1828,7 +1828,7 @@
           <p:cNvPr id="4" name="cover-subtitle">
             <a:extLst xmlns:a="http://schemas.openxmlformats.org/drawingml/2006/main">
               <a:ext uri="{FF2B5EF4-FFF2-40B4-BE49-F238E27FC236}">
-                <a16:creationId xmlns:a16="http://schemas.microsoft.com/office/drawing/2014/main" id="{1E9A1DD8-B66F-40AA-B1BD-DA242DE62815}"/>
+                <a16:creationId xmlns:a16="http://schemas.microsoft.com/office/drawing/2014/main" id="{B0F03CDF-1779-4354-A331-C2C795CC700E}"/>
               </a:ext>
             </a:extLst>
           </p:cNvPr>
@@ -1883,7 +1883,7 @@
           <p:cNvPr id="5" name="cover-statement">
             <a:extLst xmlns:a="http://schemas.openxmlformats.org/drawingml/2006/main">
               <a:ext uri="{FF2B5EF4-FFF2-40B4-BE49-F238E27FC236}">
-                <a16:creationId xmlns:a16="http://schemas.microsoft.com/office/drawing/2014/main" id="{A288CBBC-B6F6-42EA-AA11-7BE6C351CB38}"/>
+                <a16:creationId xmlns:a16="http://schemas.microsoft.com/office/drawing/2014/main" id="{F4947715-12E9-4BD0-80C5-5BDB5635AC1E}"/>
               </a:ext>
             </a:extLst>
           </p:cNvPr>
@@ -1938,7 +1938,7 @@
           <p:cNvPr id="6" name="cover-meta">
             <a:extLst xmlns:a="http://schemas.openxmlformats.org/drawingml/2006/main">
               <a:ext uri="{FF2B5EF4-FFF2-40B4-BE49-F238E27FC236}">
-                <a16:creationId xmlns:a16="http://schemas.microsoft.com/office/drawing/2014/main" id="{27C2AFB0-0B05-4738-AEA9-73ECC5073ADE}"/>
+                <a16:creationId xmlns:a16="http://schemas.microsoft.com/office/drawing/2014/main" id="{CAC90235-CA46-45F2-A09F-0E30BD14177B}"/>
               </a:ext>
             </a:extLst>
           </p:cNvPr>
@@ -1991,7 +1991,7 @@
     </p:spTree>
     <p:extLst>
       <p:ext uri="{BB962C8B-B14F-4D97-AF65-F5344CB8AC3E}">
-        <p14:creationId xmlns:p14="http://schemas.microsoft.com/office/powerpoint/2010/main" val="28254234"/>
+        <p14:creationId xmlns:p14="http://schemas.microsoft.com/office/powerpoint/2010/main" val="1820780748"/>
       </p:ext>
     </p:extLst>
   </p:cSld>
@@ -2019,10 +2019,10 @@
       </p:grpSpPr>
       <p:sp>
         <p:nvSpPr>
-          <p:cNvPr id="15" name="header-accent">
+          <p:cNvPr id="14" name="header-accent">
             <a:extLst xmlns:a="http://schemas.openxmlformats.org/drawingml/2006/main">
               <a:ext uri="{FF2B5EF4-FFF2-40B4-BE49-F238E27FC236}">
-                <a16:creationId xmlns:a16="http://schemas.microsoft.com/office/drawing/2014/main" id="{5F1EB813-00D8-4BC9-8954-F1AFFEACF7E3}"/>
+                <a16:creationId xmlns:a16="http://schemas.microsoft.com/office/drawing/2014/main" id="{CEFC65CB-E6AE-49FC-85EF-D05A309F84E4}"/>
               </a:ext>
             </a:extLst>
           </p:cNvPr>
@@ -2053,7 +2053,7 @@
           <p:cNvPr id="2" name="header-text">
             <a:extLst xmlns:a="http://schemas.openxmlformats.org/drawingml/2006/main">
               <a:ext uri="{FF2B5EF4-FFF2-40B4-BE49-F238E27FC236}">
-                <a16:creationId xmlns:a16="http://schemas.microsoft.com/office/drawing/2014/main" id="{50FA922A-3FAF-4AD3-8836-69B565D961D0}"/>
+                <a16:creationId xmlns:a16="http://schemas.microsoft.com/office/drawing/2014/main" id="{2DB5B126-E55E-495B-88BA-4203B95EBF98}"/>
               </a:ext>
             </a:extLst>
           </p:cNvPr>
@@ -2108,7 +2108,7 @@
           <p:cNvPr id="3" name="action-title">
             <a:extLst xmlns:a="http://schemas.openxmlformats.org/drawingml/2006/main">
               <a:ext uri="{FF2B5EF4-FFF2-40B4-BE49-F238E27FC236}">
-                <a16:creationId xmlns:a16="http://schemas.microsoft.com/office/drawing/2014/main" id="{7F22F2C5-4D50-443D-9292-0D96FE356B8B}"/>
+                <a16:creationId xmlns:a16="http://schemas.microsoft.com/office/drawing/2014/main" id="{B0D64A77-C849-4A4E-B9F2-76248274BC50}"/>
               </a:ext>
             </a:extLst>
           </p:cNvPr>
@@ -2163,7 +2163,7 @@
           <p:cNvPr id="4" name="subtitle">
             <a:extLst xmlns:a="http://schemas.openxmlformats.org/drawingml/2006/main">
               <a:ext uri="{FF2B5EF4-FFF2-40B4-BE49-F238E27FC236}">
-                <a16:creationId xmlns:a16="http://schemas.microsoft.com/office/drawing/2014/main" id="{30E56996-5579-4EDC-BCCA-64CDA8E4355F}"/>
+                <a16:creationId xmlns:a16="http://schemas.microsoft.com/office/drawing/2014/main" id="{9725858F-3EC7-453D-8982-793758AC7C4E}"/>
               </a:ext>
             </a:extLst>
           </p:cNvPr>
@@ -2215,41 +2215,10 @@
       </p:sp>
       <p:sp>
         <p:nvSpPr>
-          <p:cNvPr id="5" name="title-divider">
+          <p:cNvPr id="5" name="footer-divider">
             <a:extLst xmlns:a="http://schemas.openxmlformats.org/drawingml/2006/main">
               <a:ext uri="{FF2B5EF4-FFF2-40B4-BE49-F238E27FC236}">
-                <a16:creationId xmlns:a16="http://schemas.microsoft.com/office/drawing/2014/main" id="{4175C3ED-BE8C-4E6C-8272-5D3DD785BC9A}"/>
-              </a:ext>
-            </a:extLst>
-          </p:cNvPr>
-          <p:cNvSpPr>
-            <a:spLocks xmlns:a="http://schemas.openxmlformats.org/drawingml/2006/main"/>
-          </p:cNvSpPr>
-          <p:nvPr/>
-        </p:nvSpPr>
-        <p:spPr>
-          <a:xfrm xmlns:a="http://schemas.openxmlformats.org/drawingml/2006/main">
-            <a:off x="731520" y="1188720"/>
-            <a:ext cx="10728655" cy="9144"/>
-          </a:xfrm>
-          <a:prstGeom xmlns:a="http://schemas.openxmlformats.org/drawingml/2006/main" prst="rect">
-            <a:avLst/>
-          </a:prstGeom>
-          <a:solidFill xmlns:a="http://schemas.openxmlformats.org/drawingml/2006/main">
-            <a:srgbClr val="E5E6EB"/>
-          </a:solidFill>
-          <a:ln xmlns:a="http://schemas.openxmlformats.org/drawingml/2006/main" w="0">
-            <a:noFill/>
-            <a:prstDash val="solid"/>
-          </a:ln>
-        </p:spPr>
-      </p:sp>
-      <p:sp>
-        <p:nvSpPr>
-          <p:cNvPr id="6" name="footer-divider">
-            <a:extLst xmlns:a="http://schemas.openxmlformats.org/drawingml/2006/main">
-              <a:ext uri="{FF2B5EF4-FFF2-40B4-BE49-F238E27FC236}">
-                <a16:creationId xmlns:a16="http://schemas.microsoft.com/office/drawing/2014/main" id="{7FB3F879-D239-4A21-85B1-E9D58AD1D020}"/>
+                <a16:creationId xmlns:a16="http://schemas.microsoft.com/office/drawing/2014/main" id="{C82070A9-32A6-45E3-B10D-42A548BECF2B}"/>
               </a:ext>
             </a:extLst>
           </p:cNvPr>
@@ -2277,10 +2246,10 @@
       </p:sp>
       <p:sp>
         <p:nvSpPr>
-          <p:cNvPr id="7" name="source-footnote">
+          <p:cNvPr id="6" name="source-footnote">
             <a:extLst xmlns:a="http://schemas.openxmlformats.org/drawingml/2006/main">
               <a:ext uri="{FF2B5EF4-FFF2-40B4-BE49-F238E27FC236}">
-                <a16:creationId xmlns:a16="http://schemas.microsoft.com/office/drawing/2014/main" id="{EF80EC9B-68F7-464E-B124-FE4D85899AF9}"/>
+                <a16:creationId xmlns:a16="http://schemas.microsoft.com/office/drawing/2014/main" id="{DD128641-050B-4BB7-ACB7-0B6C898E0425}"/>
               </a:ext>
             </a:extLst>
           </p:cNvPr>
@@ -2332,10 +2301,10 @@
       </p:sp>
       <p:sp>
         <p:nvSpPr>
-          <p:cNvPr id="8" name="page-number">
+          <p:cNvPr id="7" name="page-number">
             <a:extLst xmlns:a="http://schemas.openxmlformats.org/drawingml/2006/main">
               <a:ext uri="{FF2B5EF4-FFF2-40B4-BE49-F238E27FC236}">
-                <a16:creationId xmlns:a16="http://schemas.microsoft.com/office/drawing/2014/main" id="{FE18A738-38D5-4F67-B3F7-20C6045D7DDD}"/>
+                <a16:creationId xmlns:a16="http://schemas.microsoft.com/office/drawing/2014/main" id="{175A5C0E-2100-4741-A977-ED6C33075476}"/>
               </a:ext>
             </a:extLst>
           </p:cNvPr>
@@ -2387,26 +2356,26 @@
       </p:sp>
       <p:graphicFrame>
         <p:nvGraphicFramePr>
-          <p:cNvPr id="23" name="chart-main"/>
+          <p:cNvPr id="21" name="chart-main"/>
           <p:cNvGraphicFramePr/>
           <p:nvPr/>
         </p:nvGraphicFramePr>
         <p:xfrm>
-          <a:off xmlns:a="http://schemas.openxmlformats.org/drawingml/2006/main" x="731520" y="1389888"/>
-          <a:ext xmlns:a="http://schemas.openxmlformats.org/drawingml/2006/main" cx="7863840" cy="4754880"/>
+          <a:off xmlns:a="http://schemas.openxmlformats.org/drawingml/2006/main" x="731520" y="1517904"/>
+          <a:ext xmlns:a="http://schemas.openxmlformats.org/drawingml/2006/main" cx="7863840" cy="4626864"/>
         </p:xfrm>
         <a:graphic xmlns:a="http://schemas.openxmlformats.org/drawingml/2006/main">
           <a:graphicData uri="http://schemas.openxmlformats.org/drawingml/2006/chart">
-            <c:chart xmlns:r="http://schemas.openxmlformats.org/officeDocument/2006/relationships" xmlns:c="http://schemas.openxmlformats.org/drawingml/2006/chart" r:id="Rcaa667a167204ed7"/>
+            <c:chart xmlns:r="http://schemas.openxmlformats.org/officeDocument/2006/relationships" xmlns:c="http://schemas.openxmlformats.org/drawingml/2006/chart" r:id="R77839587e0d44bf5"/>
           </a:graphicData>
         </a:graphic>
       </p:graphicFrame>
       <p:sp>
         <p:nvSpPr>
-          <p:cNvPr id="10" name="metric-1">
+          <p:cNvPr id="9" name="metric-1">
             <a:extLst xmlns:a="http://schemas.openxmlformats.org/drawingml/2006/main">
               <a:ext uri="{FF2B5EF4-FFF2-40B4-BE49-F238E27FC236}">
-                <a16:creationId xmlns:a16="http://schemas.microsoft.com/office/drawing/2014/main" id="{10B2BCE0-6925-432E-9B1C-7C4A28753465}"/>
+                <a16:creationId xmlns:a16="http://schemas.microsoft.com/office/drawing/2014/main" id="{C790C488-FAC0-42E4-9E74-0098C7FCC47F}"/>
               </a:ext>
             </a:extLst>
           </p:cNvPr>
@@ -2458,10 +2427,10 @@
       </p:sp>
       <p:sp>
         <p:nvSpPr>
-          <p:cNvPr id="11" name="metric-label-1">
+          <p:cNvPr id="10" name="metric-label-1">
             <a:extLst xmlns:a="http://schemas.openxmlformats.org/drawingml/2006/main">
               <a:ext uri="{FF2B5EF4-FFF2-40B4-BE49-F238E27FC236}">
-                <a16:creationId xmlns:a16="http://schemas.microsoft.com/office/drawing/2014/main" id="{DB492828-E4D2-4C4B-8E21-EB85A07AD402}"/>
+                <a16:creationId xmlns:a16="http://schemas.microsoft.com/office/drawing/2014/main" id="{E160B9B3-DE8C-499F-8D17-8E50622B1BB5}"/>
               </a:ext>
             </a:extLst>
           </p:cNvPr>
@@ -2513,10 +2482,10 @@
       </p:sp>
       <p:sp>
         <p:nvSpPr>
-          <p:cNvPr id="12" name="metric-2">
+          <p:cNvPr id="11" name="metric-2">
             <a:extLst xmlns:a="http://schemas.openxmlformats.org/drawingml/2006/main">
               <a:ext uri="{FF2B5EF4-FFF2-40B4-BE49-F238E27FC236}">
-                <a16:creationId xmlns:a16="http://schemas.microsoft.com/office/drawing/2014/main" id="{6592C578-0A65-4F8E-A0B2-92BBDBBE2411}"/>
+                <a16:creationId xmlns:a16="http://schemas.microsoft.com/office/drawing/2014/main" id="{87C2CCBF-4E69-46C3-9531-4FD4651D60B9}"/>
               </a:ext>
             </a:extLst>
           </p:cNvPr>
@@ -2568,10 +2537,10 @@
       </p:sp>
       <p:sp>
         <p:nvSpPr>
-          <p:cNvPr id="13" name="metric-label-2">
+          <p:cNvPr id="12" name="metric-label-2">
             <a:extLst xmlns:a="http://schemas.openxmlformats.org/drawingml/2006/main">
               <a:ext uri="{FF2B5EF4-FFF2-40B4-BE49-F238E27FC236}">
-                <a16:creationId xmlns:a16="http://schemas.microsoft.com/office/drawing/2014/main" id="{A6C4B93A-A815-465F-93A3-CD9A501B4CC7}"/>
+                <a16:creationId xmlns:a16="http://schemas.microsoft.com/office/drawing/2014/main" id="{6C9243BA-D7A9-493D-933A-084E46D0C79D}"/>
               </a:ext>
             </a:extLst>
           </p:cNvPr>
@@ -2623,10 +2592,10 @@
       </p:sp>
       <p:sp>
         <p:nvSpPr>
-          <p:cNvPr id="14" name="chart-reading-note">
+          <p:cNvPr id="13" name="chart-reading-note">
             <a:extLst xmlns:a="http://schemas.openxmlformats.org/drawingml/2006/main">
               <a:ext uri="{FF2B5EF4-FFF2-40B4-BE49-F238E27FC236}">
-                <a16:creationId xmlns:a16="http://schemas.microsoft.com/office/drawing/2014/main" id="{F1FA7121-9AFB-4B25-8802-FE1D61F2ADF2}"/>
+                <a16:creationId xmlns:a16="http://schemas.microsoft.com/office/drawing/2014/main" id="{C61CC0EA-FD6B-42B8-A8A0-5C9581C387E2}"/>
               </a:ext>
             </a:extLst>
           </p:cNvPr>
@@ -2679,7 +2648,7 @@
     </p:spTree>
     <p:extLst>
       <p:ext uri="{BB962C8B-B14F-4D97-AF65-F5344CB8AC3E}">
-        <p14:creationId xmlns:p14="http://schemas.microsoft.com/office/powerpoint/2010/main" val="531754223"/>
+        <p14:creationId xmlns:p14="http://schemas.microsoft.com/office/powerpoint/2010/main" val="1255341443"/>
       </p:ext>
     </p:extLst>
   </p:cSld>
@@ -2707,10 +2676,10 @@
       </p:grpSpPr>
       <p:sp>
         <p:nvSpPr>
-          <p:cNvPr id="12" name="header-accent">
+          <p:cNvPr id="11" name="header-accent">
             <a:extLst xmlns:a="http://schemas.openxmlformats.org/drawingml/2006/main">
               <a:ext uri="{FF2B5EF4-FFF2-40B4-BE49-F238E27FC236}">
-                <a16:creationId xmlns:a16="http://schemas.microsoft.com/office/drawing/2014/main" id="{53F43E48-BDE5-4977-B68A-1C835CD425CF}"/>
+                <a16:creationId xmlns:a16="http://schemas.microsoft.com/office/drawing/2014/main" id="{2FD617DE-15D9-4997-A913-2CEBDD507FA8}"/>
               </a:ext>
             </a:extLst>
           </p:cNvPr>
@@ -2741,7 +2710,7 @@
           <p:cNvPr id="2" name="header-text">
             <a:extLst xmlns:a="http://schemas.openxmlformats.org/drawingml/2006/main">
               <a:ext uri="{FF2B5EF4-FFF2-40B4-BE49-F238E27FC236}">
-                <a16:creationId xmlns:a16="http://schemas.microsoft.com/office/drawing/2014/main" id="{28637BD6-8EC4-4F17-BE0B-F695A85A078B}"/>
+                <a16:creationId xmlns:a16="http://schemas.microsoft.com/office/drawing/2014/main" id="{DC4F4948-A0D6-41D8-BC29-CB7A481D47C1}"/>
               </a:ext>
             </a:extLst>
           </p:cNvPr>
@@ -2796,7 +2765,7 @@
           <p:cNvPr id="3" name="action-title">
             <a:extLst xmlns:a="http://schemas.openxmlformats.org/drawingml/2006/main">
               <a:ext uri="{FF2B5EF4-FFF2-40B4-BE49-F238E27FC236}">
-                <a16:creationId xmlns:a16="http://schemas.microsoft.com/office/drawing/2014/main" id="{8DE1E7F2-B211-4F33-A690-CE3E362E60CA}"/>
+                <a16:creationId xmlns:a16="http://schemas.microsoft.com/office/drawing/2014/main" id="{2E2588F7-8B84-4FC9-B551-A9B849EB79A6}"/>
               </a:ext>
             </a:extLst>
           </p:cNvPr>
@@ -2848,41 +2817,10 @@
       </p:sp>
       <p:sp>
         <p:nvSpPr>
-          <p:cNvPr id="4" name="title-divider">
+          <p:cNvPr id="4" name="footer-divider">
             <a:extLst xmlns:a="http://schemas.openxmlformats.org/drawingml/2006/main">
               <a:ext uri="{FF2B5EF4-FFF2-40B4-BE49-F238E27FC236}">
-                <a16:creationId xmlns:a16="http://schemas.microsoft.com/office/drawing/2014/main" id="{B475D141-EAB7-4911-A3B7-8F85B4DDF1BF}"/>
-              </a:ext>
-            </a:extLst>
-          </p:cNvPr>
-          <p:cNvSpPr>
-            <a:spLocks xmlns:a="http://schemas.openxmlformats.org/drawingml/2006/main"/>
-          </p:cNvSpPr>
-          <p:nvPr/>
-        </p:nvSpPr>
-        <p:spPr>
-          <a:xfrm xmlns:a="http://schemas.openxmlformats.org/drawingml/2006/main">
-            <a:off x="731520" y="1005840"/>
-            <a:ext cx="10728655" cy="9144"/>
-          </a:xfrm>
-          <a:prstGeom xmlns:a="http://schemas.openxmlformats.org/drawingml/2006/main" prst="rect">
-            <a:avLst/>
-          </a:prstGeom>
-          <a:solidFill xmlns:a="http://schemas.openxmlformats.org/drawingml/2006/main">
-            <a:srgbClr val="E5E6EB"/>
-          </a:solidFill>
-          <a:ln xmlns:a="http://schemas.openxmlformats.org/drawingml/2006/main" w="0">
-            <a:noFill/>
-            <a:prstDash val="solid"/>
-          </a:ln>
-        </p:spPr>
-      </p:sp>
-      <p:sp>
-        <p:nvSpPr>
-          <p:cNvPr id="5" name="footer-divider">
-            <a:extLst xmlns:a="http://schemas.openxmlformats.org/drawingml/2006/main">
-              <a:ext uri="{FF2B5EF4-FFF2-40B4-BE49-F238E27FC236}">
-                <a16:creationId xmlns:a16="http://schemas.microsoft.com/office/drawing/2014/main" id="{8E8E3267-FC6E-42CD-9DBC-F83CB60CF2C8}"/>
+                <a16:creationId xmlns:a16="http://schemas.microsoft.com/office/drawing/2014/main" id="{6B03C171-C1C2-4168-A2E4-7244E29C445E}"/>
               </a:ext>
             </a:extLst>
           </p:cNvPr>
@@ -2910,10 +2848,10 @@
       </p:sp>
       <p:sp>
         <p:nvSpPr>
-          <p:cNvPr id="6" name="source-footnote">
+          <p:cNvPr id="5" name="source-footnote">
             <a:extLst xmlns:a="http://schemas.openxmlformats.org/drawingml/2006/main">
               <a:ext uri="{FF2B5EF4-FFF2-40B4-BE49-F238E27FC236}">
-                <a16:creationId xmlns:a16="http://schemas.microsoft.com/office/drawing/2014/main" id="{B6A56B76-0EB3-46C4-9576-7C69DA012BA1}"/>
+                <a16:creationId xmlns:a16="http://schemas.microsoft.com/office/drawing/2014/main" id="{C52227B7-0489-4DC0-8BDA-F1F7D72DB9FC}"/>
               </a:ext>
             </a:extLst>
           </p:cNvPr>
@@ -2965,10 +2903,10 @@
       </p:sp>
       <p:sp>
         <p:nvSpPr>
-          <p:cNvPr id="7" name="page-number">
+          <p:cNvPr id="6" name="page-number">
             <a:extLst xmlns:a="http://schemas.openxmlformats.org/drawingml/2006/main">
               <a:ext uri="{FF2B5EF4-FFF2-40B4-BE49-F238E27FC236}">
-                <a16:creationId xmlns:a16="http://schemas.microsoft.com/office/drawing/2014/main" id="{825B436A-9E66-455C-9FA0-C9861339EDAE}"/>
+                <a16:creationId xmlns:a16="http://schemas.microsoft.com/office/drawing/2014/main" id="{E1D92FC6-ED50-440D-B23C-D1D865E457E3}"/>
               </a:ext>
             </a:extLst>
           </p:cNvPr>
@@ -3020,7 +2958,7 @@
       </p:sp>
       <p:graphicFrame>
         <p:nvGraphicFramePr>
-          <p:cNvPr id="19" name="table-main"/>
+          <p:cNvPr id="17" name="table-main"/>
           <p:cNvGraphicFramePr/>
           <p:nvPr/>
         </p:nvGraphicFramePr>
@@ -4157,10 +4095,10 @@
       </p:graphicFrame>
       <p:sp>
         <p:nvSpPr>
-          <p:cNvPr id="9" name="table-total-rule">
+          <p:cNvPr id="8" name="table-total-rule">
             <a:extLst xmlns:a="http://schemas.openxmlformats.org/drawingml/2006/main">
               <a:ext uri="{FF2B5EF4-FFF2-40B4-BE49-F238E27FC236}">
-                <a16:creationId xmlns:a16="http://schemas.microsoft.com/office/drawing/2014/main" id="{10AEE45B-1C63-4DD6-87EF-7C3CBEB2878F}"/>
+                <a16:creationId xmlns:a16="http://schemas.microsoft.com/office/drawing/2014/main" id="{4CB4F3D9-FF14-48C6-BEAC-8B37E9043F93}"/>
               </a:ext>
             </a:extLst>
           </p:cNvPr>
@@ -4188,10 +4126,10 @@
       </p:sp>
       <p:sp>
         <p:nvSpPr>
-          <p:cNvPr id="10" name="insight-panel-accent">
+          <p:cNvPr id="9" name="insight-panel-accent">
             <a:extLst xmlns:a="http://schemas.openxmlformats.org/drawingml/2006/main">
               <a:ext uri="{FF2B5EF4-FFF2-40B4-BE49-F238E27FC236}">
-                <a16:creationId xmlns:a16="http://schemas.microsoft.com/office/drawing/2014/main" id="{96A186C4-0D85-4A3F-8E46-413FD7F2E91E}"/>
+                <a16:creationId xmlns:a16="http://schemas.microsoft.com/office/drawing/2014/main" id="{77BE4642-FDDB-4B7F-8A4C-DCEC7057D876}"/>
               </a:ext>
             </a:extLst>
           </p:cNvPr>
@@ -4219,10 +4157,10 @@
       </p:sp>
       <p:sp>
         <p:nvSpPr>
-          <p:cNvPr id="11" name="insight-panel">
+          <p:cNvPr id="10" name="insight-panel">
             <a:extLst xmlns:a="http://schemas.openxmlformats.org/drawingml/2006/main">
               <a:ext uri="{FF2B5EF4-FFF2-40B4-BE49-F238E27FC236}">
-                <a16:creationId xmlns:a16="http://schemas.microsoft.com/office/drawing/2014/main" id="{F67E8526-B5A9-4728-8236-E267FC6A134D}"/>
+                <a16:creationId xmlns:a16="http://schemas.microsoft.com/office/drawing/2014/main" id="{DE1F2060-87F0-464B-967C-530BC4734D28}"/>
               </a:ext>
             </a:extLst>
           </p:cNvPr>
@@ -4387,7 +4325,7 @@
     </p:spTree>
     <p:extLst>
       <p:ext uri="{BB962C8B-B14F-4D97-AF65-F5344CB8AC3E}">
-        <p14:creationId xmlns:p14="http://schemas.microsoft.com/office/powerpoint/2010/main" val="100635959"/>
+        <p14:creationId xmlns:p14="http://schemas.microsoft.com/office/powerpoint/2010/main" val="883220005"/>
       </p:ext>
     </p:extLst>
   </p:cSld>
@@ -4415,10 +4353,10 @@
       </p:grpSpPr>
       <p:sp>
         <p:nvSpPr>
-          <p:cNvPr id="11" name="header-accent">
+          <p:cNvPr id="10" name="header-accent">
             <a:extLst xmlns:a="http://schemas.openxmlformats.org/drawingml/2006/main">
               <a:ext uri="{FF2B5EF4-FFF2-40B4-BE49-F238E27FC236}">
-                <a16:creationId xmlns:a16="http://schemas.microsoft.com/office/drawing/2014/main" id="{B0E78E86-32A0-46B3-965F-62D3160E8544}"/>
+                <a16:creationId xmlns:a16="http://schemas.microsoft.com/office/drawing/2014/main" id="{57F9809A-C3D8-477F-85C8-D4E1712CB77C}"/>
               </a:ext>
             </a:extLst>
           </p:cNvPr>
@@ -4449,7 +4387,7 @@
           <p:cNvPr id="2" name="header-text">
             <a:extLst xmlns:a="http://schemas.openxmlformats.org/drawingml/2006/main">
               <a:ext uri="{FF2B5EF4-FFF2-40B4-BE49-F238E27FC236}">
-                <a16:creationId xmlns:a16="http://schemas.microsoft.com/office/drawing/2014/main" id="{4E3219D7-7697-4423-9BE6-D53ABFD7B989}"/>
+                <a16:creationId xmlns:a16="http://schemas.microsoft.com/office/drawing/2014/main" id="{96F0C71A-A7BE-464C-8078-1A971D46C905}"/>
               </a:ext>
             </a:extLst>
           </p:cNvPr>
@@ -4504,7 +4442,7 @@
           <p:cNvPr id="3" name="action-title">
             <a:extLst xmlns:a="http://schemas.openxmlformats.org/drawingml/2006/main">
               <a:ext uri="{FF2B5EF4-FFF2-40B4-BE49-F238E27FC236}">
-                <a16:creationId xmlns:a16="http://schemas.microsoft.com/office/drawing/2014/main" id="{FFA4961C-B485-440B-9FD6-54720E568168}"/>
+                <a16:creationId xmlns:a16="http://schemas.microsoft.com/office/drawing/2014/main" id="{019A34C7-AE77-40F7-9BBE-3EE69A69D18A}"/>
               </a:ext>
             </a:extLst>
           </p:cNvPr>
@@ -4556,41 +4494,10 @@
       </p:sp>
       <p:sp>
         <p:nvSpPr>
-          <p:cNvPr id="4" name="title-divider">
+          <p:cNvPr id="4" name="footer-divider">
             <a:extLst xmlns:a="http://schemas.openxmlformats.org/drawingml/2006/main">
               <a:ext uri="{FF2B5EF4-FFF2-40B4-BE49-F238E27FC236}">
-                <a16:creationId xmlns:a16="http://schemas.microsoft.com/office/drawing/2014/main" id="{57DFC488-AF02-41A7-B0BF-0618D9C16144}"/>
-              </a:ext>
-            </a:extLst>
-          </p:cNvPr>
-          <p:cNvSpPr>
-            <a:spLocks xmlns:a="http://schemas.openxmlformats.org/drawingml/2006/main"/>
-          </p:cNvSpPr>
-          <p:nvPr/>
-        </p:nvSpPr>
-        <p:spPr>
-          <a:xfrm xmlns:a="http://schemas.openxmlformats.org/drawingml/2006/main">
-            <a:off x="731520" y="1005840"/>
-            <a:ext cx="10728655" cy="9144"/>
-          </a:xfrm>
-          <a:prstGeom xmlns:a="http://schemas.openxmlformats.org/drawingml/2006/main" prst="rect">
-            <a:avLst/>
-          </a:prstGeom>
-          <a:solidFill xmlns:a="http://schemas.openxmlformats.org/drawingml/2006/main">
-            <a:srgbClr val="E5E6EB"/>
-          </a:solidFill>
-          <a:ln xmlns:a="http://schemas.openxmlformats.org/drawingml/2006/main" w="0">
-            <a:noFill/>
-            <a:prstDash val="solid"/>
-          </a:ln>
-        </p:spPr>
-      </p:sp>
-      <p:sp>
-        <p:nvSpPr>
-          <p:cNvPr id="5" name="footer-divider">
-            <a:extLst xmlns:a="http://schemas.openxmlformats.org/drawingml/2006/main">
-              <a:ext uri="{FF2B5EF4-FFF2-40B4-BE49-F238E27FC236}">
-                <a16:creationId xmlns:a16="http://schemas.microsoft.com/office/drawing/2014/main" id="{EAD40077-2841-4ECA-A563-4AE009220837}"/>
+                <a16:creationId xmlns:a16="http://schemas.microsoft.com/office/drawing/2014/main" id="{89767F88-E960-4D3D-861A-890F1530431A}"/>
               </a:ext>
             </a:extLst>
           </p:cNvPr>
@@ -4618,10 +4525,10 @@
       </p:sp>
       <p:sp>
         <p:nvSpPr>
-          <p:cNvPr id="6" name="source-footnote">
+          <p:cNvPr id="5" name="source-footnote">
             <a:extLst xmlns:a="http://schemas.openxmlformats.org/drawingml/2006/main">
               <a:ext uri="{FF2B5EF4-FFF2-40B4-BE49-F238E27FC236}">
-                <a16:creationId xmlns:a16="http://schemas.microsoft.com/office/drawing/2014/main" id="{10A891A2-B6E3-4D7D-B53B-F4DE3D4426DE}"/>
+                <a16:creationId xmlns:a16="http://schemas.microsoft.com/office/drawing/2014/main" id="{FCDD2CC6-4120-4984-A805-650549E05D79}"/>
               </a:ext>
             </a:extLst>
           </p:cNvPr>
@@ -4673,10 +4580,10 @@
       </p:sp>
       <p:sp>
         <p:nvSpPr>
-          <p:cNvPr id="7" name="page-number">
+          <p:cNvPr id="6" name="page-number">
             <a:extLst xmlns:a="http://schemas.openxmlformats.org/drawingml/2006/main">
               <a:ext uri="{FF2B5EF4-FFF2-40B4-BE49-F238E27FC236}">
-                <a16:creationId xmlns:a16="http://schemas.microsoft.com/office/drawing/2014/main" id="{631BFD7B-4ABF-44F0-A807-72B3B8D7D6E7}"/>
+                <a16:creationId xmlns:a16="http://schemas.microsoft.com/office/drawing/2014/main" id="{C5BC0FE6-158C-4745-BA00-DCEB7582BBD6}"/>
               </a:ext>
             </a:extLst>
           </p:cNvPr>
@@ -4728,10 +4635,10 @@
       </p:sp>
       <p:sp>
         <p:nvSpPr>
-          <p:cNvPr id="8" name="column-divider">
+          <p:cNvPr id="7" name="column-divider">
             <a:extLst xmlns:a="http://schemas.openxmlformats.org/drawingml/2006/main">
               <a:ext uri="{FF2B5EF4-FFF2-40B4-BE49-F238E27FC236}">
-                <a16:creationId xmlns:a16="http://schemas.microsoft.com/office/drawing/2014/main" id="{B0A83B15-8F6E-4B4E-8C80-354027E1DB87}"/>
+                <a16:creationId xmlns:a16="http://schemas.microsoft.com/office/drawing/2014/main" id="{09DDA7DD-C283-4474-9D74-B7E95D164E41}"/>
               </a:ext>
             </a:extLst>
           </p:cNvPr>
@@ -4742,8 +4649,8 @@
         </p:nvSpPr>
         <p:spPr>
           <a:xfrm xmlns:a="http://schemas.openxmlformats.org/drawingml/2006/main">
-            <a:off x="6094476" y="1225296"/>
-            <a:ext cx="9144" cy="4718304"/>
+            <a:off x="6094476" y="1463040"/>
+            <a:ext cx="9144" cy="4480560"/>
           </a:xfrm>
           <a:prstGeom xmlns:a="http://schemas.openxmlformats.org/drawingml/2006/main" prst="rect">
             <a:avLst/>
@@ -4759,10 +4666,10 @@
       </p:sp>
       <p:sp>
         <p:nvSpPr>
-          <p:cNvPr id="9" name="column-left">
+          <p:cNvPr id="8" name="column-left">
             <a:extLst xmlns:a="http://schemas.openxmlformats.org/drawingml/2006/main">
               <a:ext uri="{FF2B5EF4-FFF2-40B4-BE49-F238E27FC236}">
-                <a16:creationId xmlns:a16="http://schemas.microsoft.com/office/drawing/2014/main" id="{02C7D857-9126-4B0C-8870-173DE3024A66}"/>
+                <a16:creationId xmlns:a16="http://schemas.microsoft.com/office/drawing/2014/main" id="{35225C95-C2CC-4E3D-8B1F-9528126CC5E6}"/>
               </a:ext>
             </a:extLst>
           </p:cNvPr>
@@ -4773,8 +4680,8 @@
         </p:nvSpPr>
         <p:spPr>
           <a:xfrm xmlns:a="http://schemas.openxmlformats.org/drawingml/2006/main">
-            <a:off x="731520" y="1225296"/>
-            <a:ext cx="5202936" cy="4718304"/>
+            <a:off x="731520" y="1463040"/>
+            <a:ext cx="5202936" cy="4480560"/>
           </a:xfrm>
           <a:prstGeom xmlns:a="http://schemas.openxmlformats.org/drawingml/2006/main" prst="rect">
             <a:avLst/>
@@ -4954,10 +4861,10 @@
       </p:sp>
       <p:sp>
         <p:nvSpPr>
-          <p:cNvPr id="10" name="column-right">
+          <p:cNvPr id="9" name="column-right">
             <a:extLst xmlns:a="http://schemas.openxmlformats.org/drawingml/2006/main">
               <a:ext uri="{FF2B5EF4-FFF2-40B4-BE49-F238E27FC236}">
-                <a16:creationId xmlns:a16="http://schemas.microsoft.com/office/drawing/2014/main" id="{E3AC8DEA-C52A-4863-A5C0-DE2BDEEF71C9}"/>
+                <a16:creationId xmlns:a16="http://schemas.microsoft.com/office/drawing/2014/main" id="{DB51EBBF-435E-4C0C-9E30-FD85563C8DB6}"/>
               </a:ext>
             </a:extLst>
           </p:cNvPr>
@@ -4968,8 +4875,8 @@
         </p:nvSpPr>
         <p:spPr>
           <a:xfrm xmlns:a="http://schemas.openxmlformats.org/drawingml/2006/main">
-            <a:off x="6254496" y="1225296"/>
-            <a:ext cx="5202936" cy="4718304"/>
+            <a:off x="6254496" y="1463040"/>
+            <a:ext cx="5202936" cy="4480560"/>
           </a:xfrm>
           <a:prstGeom xmlns:a="http://schemas.openxmlformats.org/drawingml/2006/main" prst="rect">
             <a:avLst/>
@@ -5150,7 +5057,7 @@
     </p:spTree>
     <p:extLst>
       <p:ext uri="{BB962C8B-B14F-4D97-AF65-F5344CB8AC3E}">
-        <p14:creationId xmlns:p14="http://schemas.microsoft.com/office/powerpoint/2010/main" val="1564166286"/>
+        <p14:creationId xmlns:p14="http://schemas.microsoft.com/office/powerpoint/2010/main" val="838729374"/>
       </p:ext>
     </p:extLst>
   </p:cSld>
@@ -5178,10 +5085,10 @@
       </p:grpSpPr>
       <p:sp>
         <p:nvSpPr>
-          <p:cNvPr id="17" name="header-accent">
+          <p:cNvPr id="16" name="header-accent">
             <a:extLst xmlns:a="http://schemas.openxmlformats.org/drawingml/2006/main">
               <a:ext uri="{FF2B5EF4-FFF2-40B4-BE49-F238E27FC236}">
-                <a16:creationId xmlns:a16="http://schemas.microsoft.com/office/drawing/2014/main" id="{46B4CF8C-6E2C-479A-B1D2-5F2A66960A66}"/>
+                <a16:creationId xmlns:a16="http://schemas.microsoft.com/office/drawing/2014/main" id="{1C818079-F98B-4029-AB83-C7FA88E41371}"/>
               </a:ext>
             </a:extLst>
           </p:cNvPr>
@@ -5212,7 +5119,7 @@
           <p:cNvPr id="2" name="header-text">
             <a:extLst xmlns:a="http://schemas.openxmlformats.org/drawingml/2006/main">
               <a:ext uri="{FF2B5EF4-FFF2-40B4-BE49-F238E27FC236}">
-                <a16:creationId xmlns:a16="http://schemas.microsoft.com/office/drawing/2014/main" id="{F4C0D8EC-FEBD-41D4-B7D4-D66EA72F2577}"/>
+                <a16:creationId xmlns:a16="http://schemas.microsoft.com/office/drawing/2014/main" id="{312EE1AD-E78B-4196-B5B6-D994DAE9ECEF}"/>
               </a:ext>
             </a:extLst>
           </p:cNvPr>
@@ -5267,7 +5174,7 @@
           <p:cNvPr id="3" name="action-title">
             <a:extLst xmlns:a="http://schemas.openxmlformats.org/drawingml/2006/main">
               <a:ext uri="{FF2B5EF4-FFF2-40B4-BE49-F238E27FC236}">
-                <a16:creationId xmlns:a16="http://schemas.microsoft.com/office/drawing/2014/main" id="{BFB5E43A-EEC8-415C-91BD-FF92D4D589AF}"/>
+                <a16:creationId xmlns:a16="http://schemas.microsoft.com/office/drawing/2014/main" id="{658C28BF-78AF-4649-A110-3B40BE263B22}"/>
               </a:ext>
             </a:extLst>
           </p:cNvPr>
@@ -5279,7 +5186,7 @@
         <p:spPr>
           <a:xfrm xmlns:a="http://schemas.openxmlformats.org/drawingml/2006/main">
             <a:off x="731520" y="502920"/>
-            <a:ext cx="10728655" cy="658368"/>
+            <a:ext cx="10728655" cy="365760"/>
           </a:xfrm>
           <a:prstGeom xmlns:a="http://schemas.openxmlformats.org/drawingml/2006/main" prst="rect">
             <a:avLst/>
@@ -5312,68 +5219,17 @@
                 <a:ea typeface="PingFang SC"/>
                 <a:cs typeface="PingFang SC"/>
               </a:rPr>
-              <a:t>端到端流程通过四个原生节点形成闭环，</a:t>
-            </a:r>
-          </a:p>
-          <a:p xmlns:a="http://schemas.openxmlformats.org/drawingml/2006/main">
-            <a:pPr algn="l">
-              <a:defRPr sz="2200">
-                <a:solidFill>
-                  <a:srgbClr val="1F2329"/>
-                </a:solidFill>
-                <a:latin typeface="PingFang SC"/>
-                <a:ea typeface="PingFang SC"/>
-                <a:cs typeface="PingFang SC"/>
-              </a:defRPr>
-            </a:pPr>
-            <a:r>
-              <a:rPr sz="2200" b="1">
-                <a:latin typeface="PingFang SC"/>
-                <a:ea typeface="PingFang SC"/>
-                <a:cs typeface="PingFang SC"/>
-              </a:rPr>
-              <a:t>反馈连接器将复核结果重新带回输入端</a:t>
+              <a:t>四个原生节点串联端到端流程，复核反馈闭环返回输入端</a:t>
             </a:r>
           </a:p>
         </p:txBody>
       </p:sp>
       <p:sp>
         <p:nvSpPr>
-          <p:cNvPr id="4" name="title-divider">
+          <p:cNvPr id="4" name="footer-divider">
             <a:extLst xmlns:a="http://schemas.openxmlformats.org/drawingml/2006/main">
               <a:ext uri="{FF2B5EF4-FFF2-40B4-BE49-F238E27FC236}">
-                <a16:creationId xmlns:a16="http://schemas.microsoft.com/office/drawing/2014/main" id="{5099E02D-1B9F-4EFD-BAFB-EFD17B79E323}"/>
-              </a:ext>
-            </a:extLst>
-          </p:cNvPr>
-          <p:cNvSpPr>
-            <a:spLocks xmlns:a="http://schemas.openxmlformats.org/drawingml/2006/main"/>
-          </p:cNvSpPr>
-          <p:nvPr/>
-        </p:nvSpPr>
-        <p:spPr>
-          <a:xfrm xmlns:a="http://schemas.openxmlformats.org/drawingml/2006/main">
-            <a:off x="731520" y="1261872"/>
-            <a:ext cx="10728655" cy="9144"/>
-          </a:xfrm>
-          <a:prstGeom xmlns:a="http://schemas.openxmlformats.org/drawingml/2006/main" prst="rect">
-            <a:avLst/>
-          </a:prstGeom>
-          <a:solidFill xmlns:a="http://schemas.openxmlformats.org/drawingml/2006/main">
-            <a:srgbClr val="E5E6EB"/>
-          </a:solidFill>
-          <a:ln xmlns:a="http://schemas.openxmlformats.org/drawingml/2006/main" w="0">
-            <a:noFill/>
-            <a:prstDash val="solid"/>
-          </a:ln>
-        </p:spPr>
-      </p:sp>
-      <p:sp>
-        <p:nvSpPr>
-          <p:cNvPr id="5" name="footer-divider">
-            <a:extLst xmlns:a="http://schemas.openxmlformats.org/drawingml/2006/main">
-              <a:ext uri="{FF2B5EF4-FFF2-40B4-BE49-F238E27FC236}">
-                <a16:creationId xmlns:a16="http://schemas.microsoft.com/office/drawing/2014/main" id="{5751FE29-D21E-4C2B-9BA2-4B06D3AC8F55}"/>
+                <a16:creationId xmlns:a16="http://schemas.microsoft.com/office/drawing/2014/main" id="{1BF7C8F3-AABA-4D37-A352-A70AC91209D5}"/>
               </a:ext>
             </a:extLst>
           </p:cNvPr>
@@ -5401,10 +5257,10 @@
       </p:sp>
       <p:sp>
         <p:nvSpPr>
-          <p:cNvPr id="6" name="source-footnote">
+          <p:cNvPr id="5" name="source-footnote">
             <a:extLst xmlns:a="http://schemas.openxmlformats.org/drawingml/2006/main">
               <a:ext uri="{FF2B5EF4-FFF2-40B4-BE49-F238E27FC236}">
-                <a16:creationId xmlns:a16="http://schemas.microsoft.com/office/drawing/2014/main" id="{2BC08B21-780C-4EAE-B269-8BCBB7B8C44D}"/>
+                <a16:creationId xmlns:a16="http://schemas.microsoft.com/office/drawing/2014/main" id="{F8DB320A-543B-4071-81FF-FBB9F28444D5}"/>
               </a:ext>
             </a:extLst>
           </p:cNvPr>
@@ -5456,10 +5312,10 @@
       </p:sp>
       <p:sp>
         <p:nvSpPr>
-          <p:cNvPr id="7" name="page-number">
+          <p:cNvPr id="6" name="page-number">
             <a:extLst xmlns:a="http://schemas.openxmlformats.org/drawingml/2006/main">
               <a:ext uri="{FF2B5EF4-FFF2-40B4-BE49-F238E27FC236}">
-                <a16:creationId xmlns:a16="http://schemas.microsoft.com/office/drawing/2014/main" id="{D5CC056F-320B-4601-9155-6A43C6E3A31E}"/>
+                <a16:creationId xmlns:a16="http://schemas.microsoft.com/office/drawing/2014/main" id="{EBD07F49-E867-47E4-BC7C-093380B4A2D0}"/>
               </a:ext>
             </a:extLst>
           </p:cNvPr>
@@ -5511,10 +5367,10 @@
       </p:sp>
       <p:sp>
         <p:nvSpPr>
-          <p:cNvPr id="8" name="process-node-1">
+          <p:cNvPr id="7" name="process-node-1">
             <a:extLst xmlns:a="http://schemas.openxmlformats.org/drawingml/2006/main">
               <a:ext uri="{FF2B5EF4-FFF2-40B4-BE49-F238E27FC236}">
-                <a16:creationId xmlns:a16="http://schemas.microsoft.com/office/drawing/2014/main" id="{E377C120-4C9A-4C07-99A2-E7E88801F32E}"/>
+                <a16:creationId xmlns:a16="http://schemas.microsoft.com/office/drawing/2014/main" id="{9136B2D2-45C7-46B9-817E-11B207775016}"/>
               </a:ext>
             </a:extLst>
           </p:cNvPr>
@@ -5610,10 +5466,10 @@
       </p:sp>
       <p:sp>
         <p:nvSpPr>
-          <p:cNvPr id="9" name="process-node-2">
+          <p:cNvPr id="8" name="process-node-2">
             <a:extLst xmlns:a="http://schemas.openxmlformats.org/drawingml/2006/main">
               <a:ext uri="{FF2B5EF4-FFF2-40B4-BE49-F238E27FC236}">
-                <a16:creationId xmlns:a16="http://schemas.microsoft.com/office/drawing/2014/main" id="{EDEFCE85-52DB-4723-8534-187EC241B264}"/>
+                <a16:creationId xmlns:a16="http://schemas.microsoft.com/office/drawing/2014/main" id="{AD87D25A-1093-4D7F-8101-02238280DF73}"/>
               </a:ext>
             </a:extLst>
           </p:cNvPr>
@@ -5709,10 +5565,10 @@
       </p:sp>
       <p:sp>
         <p:nvSpPr>
-          <p:cNvPr id="10" name="process-node-3">
+          <p:cNvPr id="9" name="process-node-3">
             <a:extLst xmlns:a="http://schemas.openxmlformats.org/drawingml/2006/main">
               <a:ext uri="{FF2B5EF4-FFF2-40B4-BE49-F238E27FC236}">
-                <a16:creationId xmlns:a16="http://schemas.microsoft.com/office/drawing/2014/main" id="{EBBE2CF9-F50C-4C7E-842A-5124438741DC}"/>
+                <a16:creationId xmlns:a16="http://schemas.microsoft.com/office/drawing/2014/main" id="{722ECC52-4AE4-475D-B6CE-F4A2DE175F4E}"/>
               </a:ext>
             </a:extLst>
           </p:cNvPr>
@@ -5809,10 +5665,10 @@
       </p:sp>
       <p:sp>
         <p:nvSpPr>
-          <p:cNvPr id="11" name="process-node-4">
+          <p:cNvPr id="10" name="process-node-4">
             <a:extLst xmlns:a="http://schemas.openxmlformats.org/drawingml/2006/main">
               <a:ext uri="{FF2B5EF4-FFF2-40B4-BE49-F238E27FC236}">
-                <a16:creationId xmlns:a16="http://schemas.microsoft.com/office/drawing/2014/main" id="{10A305C7-3B5D-4D48-9639-8B09ED1FB5B5}"/>
+                <a16:creationId xmlns:a16="http://schemas.microsoft.com/office/drawing/2014/main" id="{AB590C4C-96DE-4208-A4B5-D727F6FA15BF}"/>
               </a:ext>
             </a:extLst>
           </p:cNvPr>
@@ -5909,10 +5765,10 @@
       </p:sp>
       <p:cxnSp>
         <p:nvCxnSpPr>
-          <p:cNvPr id="28" name="connector-1"/>
+          <p:cNvPr id="26" name="connector-1"/>
           <p:cNvCxnSpPr>
-            <a:stCxn xmlns:a="http://schemas.openxmlformats.org/drawingml/2006/main" id="8" idx="3"/>
-            <a:endCxn xmlns:a="http://schemas.openxmlformats.org/drawingml/2006/main" id="9" idx="1"/>
+            <a:stCxn xmlns:a="http://schemas.openxmlformats.org/drawingml/2006/main" id="7" idx="3"/>
+            <a:endCxn xmlns:a="http://schemas.openxmlformats.org/drawingml/2006/main" id="8" idx="1"/>
           </p:cNvCxnSpPr>
           <p:nvPr/>
         </p:nvCxnSpPr>
@@ -5935,10 +5791,10 @@
       </p:cxnSp>
       <p:cxnSp>
         <p:nvCxnSpPr>
-          <p:cNvPr id="29" name="connector-2"/>
+          <p:cNvPr id="27" name="connector-2"/>
           <p:cNvCxnSpPr>
-            <a:stCxn xmlns:a="http://schemas.openxmlformats.org/drawingml/2006/main" id="9" idx="3"/>
-            <a:endCxn xmlns:a="http://schemas.openxmlformats.org/drawingml/2006/main" id="10" idx="1"/>
+            <a:stCxn xmlns:a="http://schemas.openxmlformats.org/drawingml/2006/main" id="8" idx="3"/>
+            <a:endCxn xmlns:a="http://schemas.openxmlformats.org/drawingml/2006/main" id="9" idx="1"/>
           </p:cNvCxnSpPr>
           <p:nvPr/>
         </p:nvCxnSpPr>
@@ -5961,10 +5817,10 @@
       </p:cxnSp>
       <p:cxnSp>
         <p:nvCxnSpPr>
-          <p:cNvPr id="30" name="connector-3"/>
+          <p:cNvPr id="28" name="connector-3"/>
           <p:cNvCxnSpPr>
-            <a:stCxn xmlns:a="http://schemas.openxmlformats.org/drawingml/2006/main" id="10" idx="3"/>
-            <a:endCxn xmlns:a="http://schemas.openxmlformats.org/drawingml/2006/main" id="11" idx="1"/>
+            <a:stCxn xmlns:a="http://schemas.openxmlformats.org/drawingml/2006/main" id="9" idx="3"/>
+            <a:endCxn xmlns:a="http://schemas.openxmlformats.org/drawingml/2006/main" id="10" idx="1"/>
           </p:cNvCxnSpPr>
           <p:nvPr/>
         </p:nvCxnSpPr>
@@ -5987,10 +5843,10 @@
       </p:cxnSp>
       <p:cxnSp>
         <p:nvCxnSpPr>
-          <p:cNvPr id="31" name="feedback-connector"/>
+          <p:cNvPr id="29" name="feedback-connector"/>
           <p:cNvCxnSpPr>
-            <a:stCxn xmlns:a="http://schemas.openxmlformats.org/drawingml/2006/main" id="11" idx="2"/>
-            <a:endCxn xmlns:a="http://schemas.openxmlformats.org/drawingml/2006/main" id="8" idx="2"/>
+            <a:stCxn xmlns:a="http://schemas.openxmlformats.org/drawingml/2006/main" id="10" idx="2"/>
+            <a:endCxn xmlns:a="http://schemas.openxmlformats.org/drawingml/2006/main" id="7" idx="2"/>
           </p:cNvCxnSpPr>
           <p:nvPr/>
         </p:nvCxnSpPr>
@@ -6013,10 +5869,10 @@
       </p:cxnSp>
       <p:sp>
         <p:nvSpPr>
-          <p:cNvPr id="16" name="feedback-label">
+          <p:cNvPr id="15" name="feedback-label">
             <a:extLst xmlns:a="http://schemas.openxmlformats.org/drawingml/2006/main">
               <a:ext uri="{FF2B5EF4-FFF2-40B4-BE49-F238E27FC236}">
-                <a16:creationId xmlns:a16="http://schemas.microsoft.com/office/drawing/2014/main" id="{A4851857-A8DC-4F88-950F-5050AC59943C}"/>
+                <a16:creationId xmlns:a16="http://schemas.microsoft.com/office/drawing/2014/main" id="{50C2F877-9BC7-4AC3-BB48-FFF540E5CA51}"/>
               </a:ext>
             </a:extLst>
           </p:cNvPr>
@@ -6069,7 +5925,7 @@
     </p:spTree>
     <p:extLst>
       <p:ext uri="{BB962C8B-B14F-4D97-AF65-F5344CB8AC3E}">
-        <p14:creationId xmlns:p14="http://schemas.microsoft.com/office/powerpoint/2010/main" val="1755627871"/>
+        <p14:creationId xmlns:p14="http://schemas.microsoft.com/office/powerpoint/2010/main" val="202375442"/>
       </p:ext>
     </p:extLst>
   </p:cSld>
@@ -6097,10 +5953,10 @@
       </p:grpSpPr>
       <p:sp>
         <p:nvSpPr>
-          <p:cNvPr id="10" name="header-accent">
+          <p:cNvPr id="9" name="header-accent">
             <a:extLst xmlns:a="http://schemas.openxmlformats.org/drawingml/2006/main">
               <a:ext uri="{FF2B5EF4-FFF2-40B4-BE49-F238E27FC236}">
-                <a16:creationId xmlns:a16="http://schemas.microsoft.com/office/drawing/2014/main" id="{554291BF-84E2-4110-BA27-BB2DA56A5867}"/>
+                <a16:creationId xmlns:a16="http://schemas.microsoft.com/office/drawing/2014/main" id="{7E1E98BA-6E29-406D-8622-584A902DAB02}"/>
               </a:ext>
             </a:extLst>
           </p:cNvPr>
@@ -6131,7 +5987,7 @@
           <p:cNvPr id="2" name="header-text">
             <a:extLst xmlns:a="http://schemas.openxmlformats.org/drawingml/2006/main">
               <a:ext uri="{FF2B5EF4-FFF2-40B4-BE49-F238E27FC236}">
-                <a16:creationId xmlns:a16="http://schemas.microsoft.com/office/drawing/2014/main" id="{6CC1186F-6006-4BDD-9792-4D1DED570076}"/>
+                <a16:creationId xmlns:a16="http://schemas.microsoft.com/office/drawing/2014/main" id="{E8C39187-7492-48E5-AC52-4E40FB3D7FB0}"/>
               </a:ext>
             </a:extLst>
           </p:cNvPr>
@@ -6186,7 +6042,7 @@
           <p:cNvPr id="3" name="action-title">
             <a:extLst xmlns:a="http://schemas.openxmlformats.org/drawingml/2006/main">
               <a:ext uri="{FF2B5EF4-FFF2-40B4-BE49-F238E27FC236}">
-                <a16:creationId xmlns:a16="http://schemas.microsoft.com/office/drawing/2014/main" id="{8DDBA627-7C8E-43FE-B139-34D800B7688F}"/>
+                <a16:creationId xmlns:a16="http://schemas.microsoft.com/office/drawing/2014/main" id="{88B1A4B1-AD92-4A19-9470-D2DBCB035DA0}"/>
               </a:ext>
             </a:extLst>
           </p:cNvPr>
@@ -6238,41 +6094,10 @@
       </p:sp>
       <p:sp>
         <p:nvSpPr>
-          <p:cNvPr id="4" name="title-divider">
+          <p:cNvPr id="4" name="footer-divider">
             <a:extLst xmlns:a="http://schemas.openxmlformats.org/drawingml/2006/main">
               <a:ext uri="{FF2B5EF4-FFF2-40B4-BE49-F238E27FC236}">
-                <a16:creationId xmlns:a16="http://schemas.microsoft.com/office/drawing/2014/main" id="{8CD85D56-FAE7-4355-8A2A-B86B63254D8D}"/>
-              </a:ext>
-            </a:extLst>
-          </p:cNvPr>
-          <p:cNvSpPr>
-            <a:spLocks xmlns:a="http://schemas.openxmlformats.org/drawingml/2006/main"/>
-          </p:cNvSpPr>
-          <p:nvPr/>
-        </p:nvSpPr>
-        <p:spPr>
-          <a:xfrm xmlns:a="http://schemas.openxmlformats.org/drawingml/2006/main">
-            <a:off x="731520" y="1005840"/>
-            <a:ext cx="10728655" cy="9144"/>
-          </a:xfrm>
-          <a:prstGeom xmlns:a="http://schemas.openxmlformats.org/drawingml/2006/main" prst="rect">
-            <a:avLst/>
-          </a:prstGeom>
-          <a:solidFill xmlns:a="http://schemas.openxmlformats.org/drawingml/2006/main">
-            <a:srgbClr val="E5E6EB"/>
-          </a:solidFill>
-          <a:ln xmlns:a="http://schemas.openxmlformats.org/drawingml/2006/main" w="0">
-            <a:noFill/>
-            <a:prstDash val="solid"/>
-          </a:ln>
-        </p:spPr>
-      </p:sp>
-      <p:sp>
-        <p:nvSpPr>
-          <p:cNvPr id="5" name="footer-divider">
-            <a:extLst xmlns:a="http://schemas.openxmlformats.org/drawingml/2006/main">
-              <a:ext uri="{FF2B5EF4-FFF2-40B4-BE49-F238E27FC236}">
-                <a16:creationId xmlns:a16="http://schemas.microsoft.com/office/drawing/2014/main" id="{12BC5EDE-7548-4E54-8E0C-B25CC6C027EC}"/>
+                <a16:creationId xmlns:a16="http://schemas.microsoft.com/office/drawing/2014/main" id="{54622703-CA3A-4A6D-997F-459942E4F9F1}"/>
               </a:ext>
             </a:extLst>
           </p:cNvPr>
@@ -6300,10 +6125,10 @@
       </p:sp>
       <p:sp>
         <p:nvSpPr>
-          <p:cNvPr id="6" name="source-footnote">
+          <p:cNvPr id="5" name="source-footnote">
             <a:extLst xmlns:a="http://schemas.openxmlformats.org/drawingml/2006/main">
               <a:ext uri="{FF2B5EF4-FFF2-40B4-BE49-F238E27FC236}">
-                <a16:creationId xmlns:a16="http://schemas.microsoft.com/office/drawing/2014/main" id="{8B269697-B605-4AC3-BC86-A647FF5FFBD3}"/>
+                <a16:creationId xmlns:a16="http://schemas.microsoft.com/office/drawing/2014/main" id="{FE313E9C-4396-4A6A-A951-0E40BE07C656}"/>
               </a:ext>
             </a:extLst>
           </p:cNvPr>
@@ -6355,10 +6180,10 @@
       </p:sp>
       <p:sp>
         <p:nvSpPr>
-          <p:cNvPr id="7" name="page-number">
+          <p:cNvPr id="6" name="page-number">
             <a:extLst xmlns:a="http://schemas.openxmlformats.org/drawingml/2006/main">
               <a:ext uri="{FF2B5EF4-FFF2-40B4-BE49-F238E27FC236}">
-                <a16:creationId xmlns:a16="http://schemas.microsoft.com/office/drawing/2014/main" id="{7DA3F46D-68F0-4882-B4E7-D555A18445B5}"/>
+                <a16:creationId xmlns:a16="http://schemas.microsoft.com/office/drawing/2014/main" id="{4316E5DC-CABD-4FAF-8619-A3DA326C0EAF}"/>
               </a:ext>
             </a:extLst>
           </p:cNvPr>
@@ -6410,10 +6235,10 @@
       </p:sp>
       <p:sp>
         <p:nvSpPr>
-          <p:cNvPr id="8" name="appendix-note">
+          <p:cNvPr id="7" name="appendix-note">
             <a:extLst xmlns:a="http://schemas.openxmlformats.org/drawingml/2006/main">
               <a:ext uri="{FF2B5EF4-FFF2-40B4-BE49-F238E27FC236}">
-                <a16:creationId xmlns:a16="http://schemas.microsoft.com/office/drawing/2014/main" id="{4D3C36A8-A50C-45BD-A5A9-FA64B0C63545}"/>
+                <a16:creationId xmlns:a16="http://schemas.microsoft.com/office/drawing/2014/main" id="{A35D4560-CD0D-489F-A4B7-27911EAA2107}"/>
               </a:ext>
             </a:extLst>
           </p:cNvPr>
@@ -6424,7 +6249,7 @@
         </p:nvSpPr>
         <p:spPr>
           <a:xfrm xmlns:a="http://schemas.openxmlformats.org/drawingml/2006/main">
-            <a:off x="731520" y="1207008"/>
+            <a:off x="731520" y="1389888"/>
             <a:ext cx="10728655" cy="256032"/>
           </a:xfrm>
           <a:prstGeom xmlns:a="http://schemas.openxmlformats.org/drawingml/2006/main" prst="rect">
@@ -6465,13 +6290,13 @@
       </p:sp>
       <p:graphicFrame>
         <p:nvGraphicFramePr>
-          <p:cNvPr id="18" name="appendix-table"/>
+          <p:cNvPr id="16" name="appendix-table"/>
           <p:cNvGraphicFramePr/>
           <p:nvPr/>
         </p:nvGraphicFramePr>
         <p:xfrm>
-          <a:off xmlns:a="http://schemas.openxmlformats.org/drawingml/2006/main" x="731520" y="1554480"/>
-          <a:ext xmlns:a="http://schemas.openxmlformats.org/drawingml/2006/main" cx="10728655" cy="4663440"/>
+          <a:off xmlns:a="http://schemas.openxmlformats.org/drawingml/2006/main" x="731520" y="1737360"/>
+          <a:ext xmlns:a="http://schemas.openxmlformats.org/drawingml/2006/main" cx="10728655" cy="4480560"/>
         </p:xfrm>
         <a:graphic xmlns:a="http://schemas.openxmlformats.org/drawingml/2006/main">
           <a:graphicData uri="http://schemas.openxmlformats.org/drawingml/2006/table">
@@ -6486,7 +6311,7 @@
                 <a:gridCol w="2377440"/>
                 <a:gridCol w="2407615"/>
               </a:tblGrid>
-              <a:tr h="582930">
+              <a:tr h="560070">
                 <a:tc>
                   <a:txBody>
                     <a:bodyPr/>
@@ -6768,7 +6593,7 @@
                   </a:tcPr>
                 </a:tc>
               </a:tr>
-              <a:tr h="582930">
+              <a:tr h="560070">
                 <a:tc>
                   <a:txBody>
                     <a:bodyPr/>
@@ -7036,7 +6861,7 @@
                   </a:tcPr>
                 </a:tc>
               </a:tr>
-              <a:tr h="582930">
+              <a:tr h="560070">
                 <a:tc>
                   <a:txBody>
                     <a:bodyPr/>
@@ -7304,7 +7129,7 @@
                   </a:tcPr>
                 </a:tc>
               </a:tr>
-              <a:tr h="582930">
+              <a:tr h="560070">
                 <a:tc>
                   <a:txBody>
                     <a:bodyPr/>
@@ -7572,7 +7397,7 @@
                   </a:tcPr>
                 </a:tc>
               </a:tr>
-              <a:tr h="582930">
+              <a:tr h="560070">
                 <a:tc>
                   <a:txBody>
                     <a:bodyPr/>
@@ -7840,7 +7665,7 @@
                   </a:tcPr>
                 </a:tc>
               </a:tr>
-              <a:tr h="582930">
+              <a:tr h="560070">
                 <a:tc>
                   <a:txBody>
                     <a:bodyPr/>
@@ -8108,7 +7933,7 @@
                   </a:tcPr>
                 </a:tc>
               </a:tr>
-              <a:tr h="582930">
+              <a:tr h="560070">
                 <a:tc>
                   <a:txBody>
                     <a:bodyPr/>
@@ -8376,7 +8201,7 @@
                   </a:tcPr>
                 </a:tc>
               </a:tr>
-              <a:tr h="582930">
+              <a:tr h="560070">
                 <a:tc>
                   <a:txBody>
                     <a:bodyPr/>
@@ -8637,7 +8462,7 @@
     </p:spTree>
     <p:extLst>
       <p:ext uri="{BB962C8B-B14F-4D97-AF65-F5344CB8AC3E}">
-        <p14:creationId xmlns:p14="http://schemas.microsoft.com/office/powerpoint/2010/main" val="653306150"/>
+        <p14:creationId xmlns:p14="http://schemas.microsoft.com/office/powerpoint/2010/main" val="517561926"/>
       </p:ext>
     </p:extLst>
   </p:cSld>

</xml_diff>